<commit_message>
Add PII permissions exception to Builder deck
PII sessions use managed tool calls instead of bypass permissions.
The interaction mode changes with the data — careful verification
when touching production logs, user data, or regulated information.
Updates narrative, content outline, slide design, and slide 46/50.

Co-Authored-By: Claude Opus 4.6 (1M context) <noreply@anthropic.com>
</commit_message>
<xml_diff>
--- a/decks/builder/builder.pptx
+++ b/decks/builder/builder.pptx
@@ -4081,7 +4081,8 @@
           <a:p>
             <a:r>
               <a:rPr lang="en-US" dirty="0"/>
-              <a:t>Bypass all permissions by default. You’re not removing safety, you’re moving it. GCP CLI not logged into prod. AWS credentials scoped to dev. The agent physically cannot touch production. Trust the gated workflow, not per-command prompts.</a:t>
+              <a:t>Bypass all permissions by default for general coding. You’re not removing safety, you’re moving it. GCP CLI not logged into prod. AWS credentials scoped to dev. The agent physically cannot touch production. Trust the gated workflow, not per-command prompts.
+The exception: PII sessions. When touching production data, you do NOT bypass — these are careful, involved sessions with managed tool calls where you verify each step. The interaction mode changes with the data.</a:t>
             </a:r>
             <a:endParaRPr lang="en-US" dirty="0"/>
           </a:p>
@@ -4521,7 +4522,7 @@
           <a:p>
             <a:r>
               <a:rPr lang="en-US" dirty="0"/>
-              <a:t>You can’t get Builder-level speed while also having access to PII through the default path. The split is deliberate: default for general coding, PII path through GCP with EU region models. The decision is per-task, not per-project.</a:t>
+              <a:t>You can’t get Builder-level speed while also having access to PII through the default path. The split is deliberate: default path uses bypass permissions for fast, full-featured general coding. PII path routes through GCP with EU region models — and critically, no bypass permissions. These are careful, involved sessions where you manage each tool call because the data is sensitive. The interaction mode changes with the data. The decision is per-task, not per-project.</a:t>
             </a:r>
             <a:endParaRPr lang="en-US" dirty="0"/>
           </a:p>
@@ -16687,6 +16688,23 @@
                 <a:ea typeface="Calibri" pitchFamily="34" charset="-122"/>
                 <a:cs typeface="Calibri" pitchFamily="34" charset="-120"/>
               </a:rPr>
+              <a:t>Managed tool calls</a:t>
+            </a:r>
+            <a:endParaRPr lang="en-US" sz="2200" dirty="0"/>
+          </a:p>
+          <a:p>
+            <a:pPr algn="ctr" indent="0" marL="0">
+              <a:buNone/>
+            </a:pPr>
+            <a:r>
+              <a:rPr lang="en-US" sz="2200" dirty="0">
+                <a:solidFill>
+                  <a:srgbClr val="1E293B"/>
+                </a:solidFill>
+                <a:latin typeface="Calibri" pitchFamily="34" charset="0"/>
+                <a:ea typeface="Calibri" pitchFamily="34" charset="-122"/>
+                <a:cs typeface="Calibri" pitchFamily="34" charset="-120"/>
+              </a:rPr>
               <a:t>Production logs, user data</a:t>
             </a:r>
             <a:endParaRPr lang="en-US" sz="2200" dirty="0"/>

</xml_diff>

<commit_message>
Rename principle 2 from "No Hidden Failures" to "Always Grounded"
Both Context7 and Firecrawl address the same root problem — the agent
quietly working from wrong or missing information — from two directions:
stale training data and silent retrieval failure. "Always grounded"
captures both dimensions. Context7 moved from "perfect context" to
"always grounded" across all four documents.

Co-Authored-By: Claude Sonnet 4.6 <noreply@anthropic.com>
</commit_message>
<xml_diff>
--- a/decks/builder/builder.pptx
+++ b/decks/builder/builder.pptx
@@ -2065,7 +2065,7 @@
           <a:p>
             <a:r>
               <a:rPr lang="en-US" dirty="0"/>
-              <a:t>Three principles — how quality keeps pace. Every tool that follows maps to one or more. Perfect context: right information, right time. No hidden failures: every error surfaced. Gated workflow: staged verification, nothing skipped.</a:t>
+              <a:t>Three principles — how quality keeps pace. Every tool that follows maps to one or more. Perfect context: right information, right time. Always grounded: two failure modes, same root cause — stale training data and silent retrieval failure. Context7 solves the first, Firecrawl solves the second. Gated workflow: staged verification, nothing skipped.</a:t>
             </a:r>
             <a:endParaRPr lang="en-US" dirty="0"/>
           </a:p>
@@ -2593,7 +2593,7 @@
           <a:p>
             <a:r>
               <a:rPr lang="en-US" dirty="0"/>
-              <a:t>Context7 fetches live, version-specific library documentation and injects it into context at prompt time. Instead of relying on stale training data, the agent works from real, current docs. Prevents hallucinated APIs, outdated patterns, wrong-version code.</a:t>
+              <a:t>Context7 fetches live, version-specific library documentation and injects it into context at prompt time. Instead of relying on stale training data, the agent works from real, current docs. Prevents hallucinated APIs, outdated patterns, wrong-version code. First half of ‘always grounded’ — live data, not training data.</a:t>
             </a:r>
             <a:endParaRPr lang="en-US" dirty="0"/>
           </a:p>
@@ -2769,7 +2769,7 @@
           <a:p>
             <a:r>
               <a:rPr lang="en-US" dirty="0"/>
-              <a:t>WebFetch gets rejected by sites, pages are too large and get truncated, content gets summarized in ways that lose critical detail — and none of this is obvious. Firecrawl handles all of this reliably.</a:t>
+              <a:t>WebFetch gets rejected by sites, pages are too large and get truncated, content gets summarized in ways that lose critical detail — and none of this is obvious. Firecrawl handles all of this reliably. Second half of ‘always grounded’ — reliable retrieval, not silent failure. Both Context7 and Firecrawl share this tag: solving the same root problem from two directions.</a:t>
             </a:r>
             <a:endParaRPr lang="en-US" dirty="0"/>
           </a:p>
@@ -5321,7 +5321,7 @@
           <a:p>
             <a:r>
               <a:rPr lang="en-US" dirty="0"/>
-              <a:t>Rapid-fire recap. Each tool maps to a principle. The gated workflow is the approach on top — powered by Superpowers, enforced through two-layer verification, backstopped by CI/CD. The audience should see the system as a whole — not individual pieces, but an integrated machine.</a:t>
+              <a:t>Rapid-fire recap. Each tool maps to a principle. ‘Always grounded’ groups Context7 and Firecrawl together — both prevent the agent from working on wrong information, from two directions. The gated workflow is the approach on top — powered by Superpowers, enforced through two-layer verification, backstopped by CI/CD.</a:t>
             </a:r>
             <a:endParaRPr lang="en-US" dirty="0"/>
           </a:p>
@@ -11271,7 +11271,7 @@
                 <a:ea typeface="Georgia" pitchFamily="34" charset="-122"/>
                 <a:cs typeface="Georgia" pitchFamily="34" charset="-120"/>
               </a:rPr>
-              <a:t>No Hidden Failures</a:t>
+              <a:t>Always Grounded</a:t>
             </a:r>
             <a:endParaRPr lang="en-US" sz="2800" dirty="0"/>
           </a:p>
@@ -11310,7 +11310,7 @@
                 <a:ea typeface="Verdana" pitchFamily="34" charset="-122"/>
                 <a:cs typeface="Verdana" pitchFamily="34" charset="-120"/>
               </a:rPr>
-              <a:t>Every failure</a:t>
+              <a:t>Live data.</a:t>
             </a:r>
             <a:endParaRPr lang="en-US" sz="2200" dirty="0"/>
           </a:p>
@@ -11327,7 +11327,7 @@
                 <a:ea typeface="Verdana" pitchFamily="34" charset="-122"/>
                 <a:cs typeface="Verdana" pitchFamily="34" charset="-120"/>
               </a:rPr>
-              <a:t>must be visible.</a:t>
+              <a:t>No silent gaps.</a:t>
             </a:r>
             <a:endParaRPr lang="en-US" sz="2200" dirty="0"/>
           </a:p>
@@ -12558,7 +12558,7 @@
                 <a:ea typeface="Verdana" pitchFamily="34" charset="-122"/>
                 <a:cs typeface="Verdana" pitchFamily="34" charset="-120"/>
               </a:rPr>
-              <a:t>perfect context</a:t>
+              <a:t>always grounded</a:t>
             </a:r>
             <a:endParaRPr lang="en-US" sz="1600" dirty="0"/>
           </a:p>
@@ -12895,7 +12895,7 @@
                 <a:ea typeface="Verdana" pitchFamily="34" charset="-122"/>
                 <a:cs typeface="Verdana" pitchFamily="34" charset="-120"/>
               </a:rPr>
-              <a:t>No silent failures.</a:t>
+              <a:t>No silent gaps.</a:t>
             </a:r>
             <a:endParaRPr lang="en-US" sz="2800" dirty="0"/>
           </a:p>
@@ -12934,7 +12934,7 @@
                 <a:ea typeface="Verdana" pitchFamily="34" charset="-122"/>
                 <a:cs typeface="Verdana" pitchFamily="34" charset="-120"/>
               </a:rPr>
-              <a:t>no hidden failures</a:t>
+              <a:t>always grounded</a:t>
             </a:r>
             <a:endParaRPr lang="en-US" sz="1600" dirty="0"/>
           </a:p>
@@ -19015,7 +19015,7 @@
                 <a:ea typeface="Verdana" pitchFamily="34" charset="-122"/>
                 <a:cs typeface="Verdana" pitchFamily="34" charset="-120"/>
               </a:rPr>
-              <a:t>  Context7, Language Servers, Rules, Monorepo</a:t>
+              <a:t>  Language Servers, Rules, Monorepo</a:t>
             </a:r>
             <a:endParaRPr lang="en-US" sz="2400" dirty="0"/>
           </a:p>
@@ -19038,7 +19038,7 @@
                 <a:ea typeface="Verdana" pitchFamily="34" charset="-122"/>
                 <a:cs typeface="Verdana" pitchFamily="34" charset="-120"/>
               </a:rPr>
-              <a:t>No hidden failures</a:t>
+              <a:t>Always grounded</a:t>
             </a:r>
             <a:endParaRPr lang="en-US" sz="2400" dirty="0"/>
           </a:p>
@@ -19055,7 +19055,7 @@
                 <a:ea typeface="Verdana" pitchFamily="34" charset="-122"/>
                 <a:cs typeface="Verdana" pitchFamily="34" charset="-120"/>
               </a:rPr>
-              <a:t>  Firecrawl, Tool usage rules</a:t>
+              <a:t>  Context7, Firecrawl, Tool usage rules</a:t>
             </a:r>
             <a:endParaRPr lang="en-US" sz="2400" dirty="0"/>
           </a:p>

</xml_diff>